<commit_message>
docs(assignment): expand ideation essay — business model, moat, compliance drivers
</commit_message>
<xml_diff>
--- a/assignment/SAAS_Ideation_Presentation.pptx
+++ b/assignment/SAAS_Ideation_Presentation.pptx
@@ -4765,7 +4765,7 @@
                 </a:solidFill>
                 <a:latin typeface="Calibri"/>
               </a:rPr>
-              <a:t>Sept 2026 · ≈ 1,030 words + 1 figure + 6 references</a:t>
+              <a:t>Sept 2026 · ≈ 1,610 words + 1 figure + 8 references</a:t>
             </a:r>
           </a:p>
         </p:txBody>
@@ -8947,7 +8947,7 @@
                 </a:solidFill>
                 <a:latin typeface="Calibri"/>
               </a:rPr>
-              <a:t>• Customer &amp; payer: the university, not the student — Registry and IT office buy an annual licence sized by student population.</a:t>
+              <a:t>• Payer: the university (Registry + IT), annual licence by student population; students &amp; instructors pay only in time.</a:t>
             </a:r>
           </a:p>
           <a:p>
@@ -8966,7 +8966,7 @@
                 </a:solidFill>
                 <a:latin typeface="Calibri"/>
               </a:rPr>
-              <a:t>• Users (students, instructors) pay in time, not money.</a:t>
+              <a:t>• Business model: 3 revenue lines — annual licence + implementation fee + configuration support.</a:t>
             </a:r>
           </a:p>
           <a:p>
@@ -8985,7 +8985,7 @@
                 </a:solidFill>
                 <a:latin typeface="Calibri"/>
               </a:rPr>
-              <a:t>• Value: makes an unmeasured cost measurable.</a:t>
+              <a:t>• Value: makes an invisible cost visible, then reduces it.</a:t>
             </a:r>
           </a:p>
           <a:p>
@@ -9004,7 +9004,7 @@
                 </a:solidFill>
                 <a:latin typeface="Calibri"/>
               </a:rPr>
-              <a:t>   – Instructor hours on absence email</a:t>
+              <a:t>   – Instructor hours on absence email &amp; ad-hoc negotiation</a:t>
             </a:r>
           </a:p>
           <a:p>
@@ -9023,7 +9023,7 @@
                 </a:solidFill>
                 <a:latin typeface="Calibri"/>
               </a:rPr>
-              <a:t>   – Administrative effort on disputes</a:t>
+              <a:t>   – Admin effort on disputes, duplicate records, manual audits</a:t>
             </a:r>
           </a:p>
           <a:p>
@@ -9042,7 +9042,7 @@
                 </a:solidFill>
                 <a:latin typeface="Calibri"/>
               </a:rPr>
-              <a:t>   – Compliance risk of holding no record</a:t>
+              <a:t>   – Compliance risk of holding no defensible record</a:t>
             </a:r>
           </a:p>
           <a:p>
@@ -9061,7 +9061,7 @@
                 </a:solidFill>
                 <a:latin typeface="Calibri"/>
               </a:rPr>
-              <a:t>• Differentiator: policy-configuration layer + portability — same product serves HKUST(GZ), HKUST, CUHK(SZ) and other institutions whose thresholds differ.</a:t>
+              <a:t>• Indicative scale: 10k students / 800 faculty → several thousand fragmented hours / yr; 30–50% reduction is material (illustrative).</a:t>
             </a:r>
           </a:p>
           <a:p>
@@ -9080,7 +9080,26 @@
                 </a:solidFill>
                 <a:latin typeface="Calibri"/>
               </a:rPr>
-              <a:t>• Needed complements: campus SSO, SIS / LMS vendors, Microsoft for delivery, cross-campus policy owners willing to harmonise.</a:t>
+              <a:t>• Moat: policy-configuration layer + portability across HKUST(GZ)/HKUST/CUHK(SZ).</a:t>
+            </a:r>
+          </a:p>
+          <a:p>
+            <a:pPr algn="l">
+              <a:lnSpc>
+                <a:spcPct val="130000"/>
+              </a:lnSpc>
+              <a:spcAft>
+                <a:spcPts val="600"/>
+              </a:spcAft>
+            </a:pPr>
+            <a:r>
+              <a:rPr sz="1200">
+                <a:solidFill>
+                  <a:srgbClr val="201F1E"/>
+                </a:solidFill>
+                <a:latin typeface="Calibri"/>
+              </a:rPr>
+              <a:t>• Compliance as a driver: UKVI / ESOS / FERPA → "regulatory defensibility" shortens sales cycles &amp; widens the market.</a:t>
             </a:r>
           </a:p>
         </p:txBody>
@@ -9625,7 +9644,7 @@
                 </a:solidFill>
                 <a:latin typeface="Calibri"/>
               </a:rPr>
-              <a:t>• Equity: outcome stops depending on which instructor you ask or how persuasive your email is.</a:t>
+              <a:t>• Equity by structure: outcome stops depending on who you ask or how persuasive your email is.</a:t>
             </a:r>
           </a:p>
           <a:p>
@@ -9663,7 +9682,7 @@
                 </a:solidFill>
                 <a:latin typeface="Calibri"/>
               </a:rPr>
-              <a:t>• Early-warning rules can reach a struggling student before failure appears in grades.</a:t>
+              <a:t>• Protects international students: visa attendance duties (UKVI / ESOS) — a legitimate absence should not become a compliance breach.</a:t>
             </a:r>
           </a:p>
           <a:p>
@@ -9682,7 +9701,7 @@
                 </a:solidFill>
                 <a:latin typeface="Calibri"/>
               </a:rPr>
-              <a:t>• Unavoidable date absences (visa appointments) cannot be rejected on grounds of date.</a:t>
+              <a:t>• Early-warning rules can reach a struggling student before grades fail — an administrative record becomes a welfare signal.</a:t>
             </a:r>
           </a:p>
         </p:txBody>

</xml_diff>